<commit_message>
Research: address external review - mediation b paths, elevated-HA label, hedged claims, refs
- Mediation: report b path adjusted for the predictor (indirect = a x b = c - c')
- SHAI >= 18 relabelled 'elevated' (not 'clinically relevant'); prevalence at 29 added
- Tool count uses the study's AI-user definition; Holm pairwise p reported
- Post-hoc power removed; abstract shortened and hedged; objectives cut to four
- Behavioural findings marked exploratory; H3/H4 verdicts stated
- Limitations: unused Arabic versions and response-option order
- ClinicalTrials.gov description corrected; missing DOIs and entry details added

Co-Authored-By: Claude Opus 5.5 <noreply@anthropic.com>
Claude-Session: https://claude.ai/code/session_0186tGPQJ67bKVgWZR7S3c4o
</commit_message>
<xml_diff>
--- a/research/output/study/Defence_Presentation.pptx
+++ b/research/output/study/Defence_Presentation.pptx
@@ -125,7 +125,7 @@
   <p:extLst>
     <p:ext uri="{521415D9-36F7-43E2-AB2F-B90AF26B5E84}">
       <p14:sectionLst xmlns:p14="http://schemas.microsoft.com/office/powerpoint/2010/main">
-        <p14:section name="Introduction" id="{1db886ff-9858-43bc-ede9-2d0d395b6c21}">
+        <p14:section name="Introduction" id="{6021526d-65a6-53fc-cfd6-c70ab6c04da4}">
           <p14:sldIdLst>
             <p14:sldId id="256"/>
             <p14:sldId id="257"/>
@@ -133,13 +133,13 @@
             <p14:sldId id="259"/>
           </p14:sldIdLst>
         </p14:section>
-        <p14:section name="Methods" id="{61fd6ac7-5b51-d443-8a7c-7e07c8e48426}">
+        <p14:section name="Methods" id="{b899928c-bd48-a8ca-b8d6-8db4e4e71231}">
           <p14:sldIdLst>
             <p14:sldId id="260"/>
             <p14:sldId id="261"/>
           </p14:sldIdLst>
         </p14:section>
-        <p14:section name="Results" id="{a15baf3a-89e7-1a91-a856-408ebc3c4bf6}">
+        <p14:section name="Results" id="{33e93fc1-0e30-b93d-1cef-ed16a0b3c952}">
           <p14:sldIdLst>
             <p14:sldId id="262"/>
             <p14:sldId id="263"/>
@@ -153,7 +153,7 @@
             <p14:sldId id="271"/>
           </p14:sldIdLst>
         </p14:section>
-        <p14:section name="Discussion" id="{bae790e6-984a-1286-d7ea-39a51aac60be}">
+        <p14:section name="Discussion" id="{040f0d08-ee6d-20b0-055f-9b63ac1fbc18}">
           <p14:sldIdLst>
             <p14:sldId id="272"/>
             <p14:sldId id="273"/>
@@ -1990,7 +1990,7 @@
           <a:p>
             <a:r>
               <a:rPr lang="en-US" dirty="0"/>
-              <a:t>Clinically relevant health anxiety is independently associated with higher cyberchondria (AOR 3.12 per SD), searching for instant reassurance (AOR 3.83) and younger age (AOR 0.61 per age step). AUC 0.83. Chronic illness predicts SHAI in linear models. Demographics explain almost none of cyberchondria (R-squared 0.030).</a:t>
+              <a:t>Elevated health anxiety is independently associated with higher cyberchondria (AOR 3.12 per SD), searching for instant reassurance (AOR 3.83) and younger age (AOR 0.61 per age step). AUC 0.83. Chronic illness predicts SHAI in linear models. Demographics explain almost none of cyberchondria (R-squared 0.030).</a:t>
             </a:r>
             <a:endParaRPr lang="en-US" dirty="0"/>
           </a:p>
@@ -2958,7 +2958,7 @@
           <a:p>
             <a:r>
               <a:rPr lang="en-US" dirty="0"/>
-              <a:t>Cross-sectional online survey in Baghdad, 17 July 2026 to 11 September 2026. Convenience and snowball sampling, n = 300. Sample size: 194 needed to detect r = 0.20 with 80% power; we had 94% power. Bilingual Google Form with SHAI-14 and CSS-12. Analysis: reliability and CFA, correlations, non-parametric tests with FDR correction, robust regression, logistic models, bootstrapped mediation and moderation, sensitivity analyses.</a:t>
+              <a:t>Cross-sectional online survey in Baghdad, 17 July 2026 to 11 September 2026. Convenience and snowball sampling, n = 300. Sample size: 194 needed to detect r = 0.20 with 80% power; our sample of 300 exceeds this. Bilingual Google Form with SHAI-14 and CSS-12. Analysis: reliability and CFA, correlations, non-parametric tests with FDR correction, robust regression, logistic models, bootstrapped mediation and moderation, sensitivity analyses.</a:t>
             </a:r>
             <a:endParaRPr lang="en-US" dirty="0"/>
           </a:p>
@@ -4215,7 +4215,7 @@
                 <a:ea typeface="Cambria" pitchFamily="34" charset="-122"/>
                 <a:cs typeface="Cambria" pitchFamily="34" charset="-120"/>
               </a:rPr>
-              <a:t>One in five has clinically relevant health anxiety</a:t>
+              <a:t>One in five has elevated health anxiety</a:t>
             </a:r>
             <a:endParaRPr lang="en-US" sz="3000" dirty="0"/>
           </a:p>
@@ -4325,7 +4325,7 @@
       </p:sp>
       <p:sp>
         <p:nvSpPr>
-          <p:cNvPr id="7" name="stat SHAI ≥ 18 (clinically relevant)"/>
+          <p:cNvPr id="7" name="stat elevated (SHAI ≥ 18)"/>
           <p:cNvSpPr/>
           <p:nvPr/>
         </p:nvSpPr>
@@ -4419,7 +4419,7 @@
                   <a:schemeClr val="tx1"/>
                 </a:solidFill>
               </a:rPr>
-              <a:t>SHAI ≥ 18 (clinically relevant)</a:t>
+              <a:t>elevated (SHAI ≥ 18)</a:t>
             </a:r>
             <a:endParaRPr lang="en-US" sz="1400" dirty="0"/>
           </a:p>
@@ -11186,7 +11186,7 @@
                   <a:schemeClr val="tx1"/>
                 </a:solidFill>
               </a:rPr>
-              <a:t>n = 300, convenience + snowball; 194 needed for r = 0.20 (power 94%)</a:t>
+              <a:t>n = 300, convenience + snowball; a priori 194 needed to detect r = 0.20</a:t>
             </a:r>
             <a:endParaRPr lang="en-US" sz="1500" dirty="0"/>
           </a:p>

</xml_diff>